<commit_message>
Change in OTP structure
</commit_message>
<xml_diff>
--- a/Bio-Crypt_Lock.pptx
+++ b/Bio-Crypt_Lock.pptx
@@ -3502,9 +3502,19 @@
                 <a:ea typeface="Calibri" pitchFamily="34" charset="-122"/>
                 <a:cs typeface="Calibri" pitchFamily="34" charset="-120"/>
               </a:rPr>
-              <a:t>Preventing replay attacks and enforcing OTP expiry</a:t>
-            </a:r>
-            <a:endParaRPr lang="en-US" sz="1150" dirty="0"/>
+              <a:t>Preventing replay attacks and enforcing </a:t>
+            </a:r>
+            <a:r>
+              <a:rPr lang="en-US" sz="1150">
+                <a:solidFill>
+                  <a:srgbClr val="262626"/>
+                </a:solidFill>
+                <a:latin typeface="Calibri" pitchFamily="34" charset="0"/>
+                <a:ea typeface="Calibri" pitchFamily="34" charset="-122"/>
+                <a:cs typeface="Calibri" pitchFamily="34" charset="-120"/>
+              </a:rPr>
+              <a:t>OTP expiry</a:t>
+            </a:r>
           </a:p>
           <a:p>
             <a:pPr marL="342900" indent="-342900">
@@ -3518,6 +3528,17 @@
               <a:buChar char="•"/>
             </a:pPr>
             <a:r>
+              <a:rPr lang="en-US" sz="1150">
+                <a:solidFill>
+                  <a:srgbClr val="262626"/>
+                </a:solidFill>
+                <a:latin typeface="Calibri" pitchFamily="34" charset="0"/>
+                <a:ea typeface="Calibri" pitchFamily="34" charset="-122"/>
+                <a:cs typeface="Calibri" pitchFamily="34" charset="-120"/>
+              </a:rPr>
+              <a:t>Handling </a:t>
+            </a:r>
+            <a:r>
               <a:rPr lang="en-US" sz="1150" dirty="0">
                 <a:solidFill>
                   <a:srgbClr val="262626"/>
@@ -3526,31 +3547,7 @@
                 <a:ea typeface="Calibri" pitchFamily="34" charset="-122"/>
                 <a:cs typeface="Calibri" pitchFamily="34" charset="-120"/>
               </a:rPr>
-              <a:t>Securing communication between the ESP32 modules and peripherals</a:t>
-            </a:r>
-            <a:endParaRPr lang="en-US" sz="1150" dirty="0"/>
-          </a:p>
-          <a:p>
-            <a:pPr marL="342900" indent="-342900">
-              <a:lnSpc>
-                <a:spcPct val="125000"/>
-              </a:lnSpc>
-              <a:spcAft>
-                <a:spcPts val="800"/>
-              </a:spcAft>
-              <a:buSzPct val="100000"/>
-              <a:buChar char="•"/>
-            </a:pPr>
-            <a:r>
-              <a:rPr lang="en-US" sz="1150" dirty="0">
-                <a:solidFill>
-                  <a:srgbClr val="262626"/>
-                </a:solidFill>
-                <a:latin typeface="Calibri" pitchFamily="34" charset="0"/>
-                <a:ea typeface="Calibri" pitchFamily="34" charset="-122"/>
-                <a:cs typeface="Calibri" pitchFamily="34" charset="-120"/>
-              </a:rPr>
-              <a:t>Handling failed attempts and lockout policy sensibly</a:t>
+              <a:t>failed attempts and lockout policy sensibly</a:t>
             </a:r>
             <a:endParaRPr lang="en-US" sz="1150" dirty="0"/>
           </a:p>
@@ -4773,7 +4770,7 @@
                 <a:ea typeface="Calibri" pitchFamily="34" charset="-122"/>
                 <a:cs typeface="Calibri" pitchFamily="34" charset="-120"/>
               </a:rPr>
-              <a:t>Fingerprint Sensor → ESP32 → Risk Evaluation → Adaptive Authentication → Cryptographic Verification → Servo / Solenoid Lock</a:t>
+              <a:t>Fingerprint Sensor → ESP32 → Risk Evaluation → Adaptive Authentication → Cryptographic Verification → Software Lock</a:t>
             </a:r>
             <a:endParaRPr lang="en-US" sz="1200" dirty="0"/>
           </a:p>

</xml_diff>